<commit_message>
Sync updated CRH-CFG poster
</commit_message>
<xml_diff>
--- a/hw4/poster/crh_cfg_poster.pptx
+++ b/hw4/poster/crh_cfg_poster.pptx
@@ -849,7 +849,7 @@
           <a:lstStyle/>
           <a:p>
             <a:fld id="{511F4129-D723-AE42-8870-A3D58B405FED}" type="datetimeFigureOut">
-              <a:t>14/07/26</a:t>
+              <a:t>15/07/26</a:t>
             </a:fld>
             <a:endParaRPr/>
           </a:p>
@@ -1044,7 +1044,7 @@
           <a:lstStyle/>
           <a:p>
             <a:fld id="{511F4129-D723-AE42-8870-A3D58B405FED}" type="datetimeFigureOut">
-              <a:t>14/07/26</a:t>
+              <a:t>15/07/26</a:t>
             </a:fld>
             <a:endParaRPr/>
           </a:p>
@@ -1249,7 +1249,7 @@
           <a:lstStyle/>
           <a:p>
             <a:fld id="{511F4129-D723-AE42-8870-A3D58B405FED}" type="datetimeFigureOut">
-              <a:t>14/07/26</a:t>
+              <a:t>15/07/26</a:t>
             </a:fld>
             <a:endParaRPr/>
           </a:p>
@@ -1444,7 +1444,7 @@
           <a:lstStyle/>
           <a:p>
             <a:fld id="{511F4129-D723-AE42-8870-A3D58B405FED}" type="datetimeFigureOut">
-              <a:t>14/07/26</a:t>
+              <a:t>15/07/26</a:t>
             </a:fld>
             <a:endParaRPr/>
           </a:p>
@@ -1713,7 +1713,7 @@
           <a:lstStyle/>
           <a:p>
             <a:fld id="{511F4129-D723-AE42-8870-A3D58B405FED}" type="datetimeFigureOut">
-              <a:t>14/07/26</a:t>
+              <a:t>15/07/26</a:t>
             </a:fld>
             <a:endParaRPr/>
           </a:p>
@@ -1980,7 +1980,7 @@
           <a:lstStyle/>
           <a:p>
             <a:fld id="{511F4129-D723-AE42-8870-A3D58B405FED}" type="datetimeFigureOut">
-              <a:t>14/07/26</a:t>
+              <a:t>15/07/26</a:t>
             </a:fld>
             <a:endParaRPr/>
           </a:p>
@@ -2396,7 +2396,7 @@
           <a:lstStyle/>
           <a:p>
             <a:fld id="{511F4129-D723-AE42-8870-A3D58B405FED}" type="datetimeFigureOut">
-              <a:t>14/07/26</a:t>
+              <a:t>15/07/26</a:t>
             </a:fld>
             <a:endParaRPr/>
           </a:p>
@@ -2529,7 +2529,7 @@
           <a:lstStyle/>
           <a:p>
             <a:fld id="{511F4129-D723-AE42-8870-A3D58B405FED}" type="datetimeFigureOut">
-              <a:t>14/07/26</a:t>
+              <a:t>15/07/26</a:t>
             </a:fld>
             <a:endParaRPr/>
           </a:p>
@@ -2635,7 +2635,7 @@
           <a:lstStyle/>
           <a:p>
             <a:fld id="{511F4129-D723-AE42-8870-A3D58B405FED}" type="datetimeFigureOut">
-              <a:t>14/07/26</a:t>
+              <a:t>15/07/26</a:t>
             </a:fld>
             <a:endParaRPr/>
           </a:p>
@@ -2954,7 +2954,7 @@
           <a:lstStyle/>
           <a:p>
             <a:fld id="{511F4129-D723-AE42-8870-A3D58B405FED}" type="datetimeFigureOut">
-              <a:t>14/07/26</a:t>
+              <a:t>15/07/26</a:t>
             </a:fld>
             <a:endParaRPr/>
           </a:p>
@@ -3238,7 +3238,7 @@
           <a:lstStyle/>
           <a:p>
             <a:fld id="{511F4129-D723-AE42-8870-A3D58B405FED}" type="datetimeFigureOut">
-              <a:t>14/07/26</a:t>
+              <a:t>15/07/26</a:t>
             </a:fld>
             <a:endParaRPr/>
           </a:p>
@@ -3477,7 +3477,7 @@
           </a:lstStyle>
           <a:p>
             <a:fld id="{511F4129-D723-AE42-8870-A3D58B405FED}" type="datetimeFigureOut">
-              <a:t>14/07/26</a:t>
+              <a:t>15/07/26</a:t>
             </a:fld>
             <a:endParaRPr/>
           </a:p>
@@ -3908,8 +3908,8 @@
         </p:nvSpPr>
         <p:spPr>
           <a:xfrm>
-            <a:off x="457200" y="323850"/>
-            <a:ext cx="18907125" cy="1920240"/>
+            <a:off x="457200" y="406807"/>
+            <a:ext cx="18907125" cy="1754326"/>
           </a:xfrm>
           <a:prstGeom prst="rect">
             <a:avLst/>
@@ -3922,7 +3922,7 @@
           </a:bodyPr>
           <a:lstStyle/>
           <a:p>
-            <a:pPr algn="l">
+            <a:pPr>
               <a:defRPr sz="5700" b="1">
                 <a:solidFill>
                   <a:srgbClr val="C41230"/>
@@ -3933,19 +3933,12 @@
               </a:defRPr>
             </a:pPr>
             <a:r>
-              <a:rPr sz="5700" b="1">
-                <a:solidFill>
-                  <a:srgbClr val="C41230"/>
-                </a:solidFill>
-                <a:latin typeface="Optima"/>
-                <a:ea typeface="Optima"/>
-                <a:cs typeface="Optima"/>
-              </a:rPr>
-              <a:t>Constraint-Aware Receding-Horizon CFG</a:t>
-            </a:r>
-          </a:p>
-          <a:p>
-            <a:pPr algn="l">
+              <a:rPr lang="en-SG" altLang="zh-SG" sz="5700" dirty="0"/>
+              <a:t>CRH-CFG: Constraint-aware Receding-Horizon Guidance</a:t>
+            </a:r>
+          </a:p>
+          <a:p>
+            <a:pPr>
               <a:defRPr sz="5700" b="1">
                 <a:solidFill>
                   <a:srgbClr val="C41230"/>
@@ -3956,16 +3949,21 @@
               </a:defRPr>
             </a:pPr>
             <a:r>
-              <a:rPr sz="5700" b="1">
-                <a:solidFill>
-                  <a:srgbClr val="C41230"/>
-                </a:solidFill>
-                <a:latin typeface="Optima"/>
-                <a:ea typeface="Optima"/>
-                <a:cs typeface="Optima"/>
-              </a:rPr>
+              <a:rPr lang="zh-CN" altLang="en-US" sz="5700"/>
+              <a:t>                  </a:t>
+            </a:r>
+            <a:r>
+              <a:rPr lang="en-SG" altLang="zh-SG" sz="5700" dirty="0"/>
               <a:t>for Attribute-Conditioned Flow Matching</a:t>
             </a:r>
+            <a:endParaRPr sz="5700" b="1" dirty="0">
+              <a:solidFill>
+                <a:srgbClr val="C41230"/>
+              </a:solidFill>
+              <a:latin typeface="Optima"/>
+              <a:ea typeface="Optima"/>
+              <a:cs typeface="Optima"/>
+            </a:endParaRPr>
           </a:p>
         </p:txBody>
       </p:sp>
@@ -4597,8 +4595,8 @@
           </a:p>
         </p:txBody>
       </p:sp>
-      <mc:AlternateContent xmlns:mc="http://schemas.openxmlformats.org/markup-compatibility/2006">
-        <mc:Choice xmlns:a14="http://schemas.microsoft.com/office/drawing/2010/main" Requires="a14">
+      <mc:AlternateContent xmlns:mc="http://schemas.openxmlformats.org/markup-compatibility/2006" xmlns:a14="http://schemas.microsoft.com/office/drawing/2010/main">
+        <mc:Choice Requires="a14">
           <p:sp>
             <p:nvSpPr>
               <p:cNvPr id="22" name="problem-copy">
@@ -4948,7 +4946,7 @@
             </p:txBody>
           </p:sp>
         </mc:Choice>
-        <mc:Fallback>
+        <mc:Fallback xmlns="">
           <p:sp>
             <p:nvSpPr>
               <p:cNvPr id="22" name="problem-copy">
@@ -5212,8 +5210,8 @@
           </a:p>
         </p:txBody>
       </p:sp>
-      <mc:AlternateContent xmlns:mc="http://schemas.openxmlformats.org/markup-compatibility/2006">
-        <mc:Choice xmlns:a14="http://schemas.microsoft.com/office/drawing/2010/main" Requires="a14">
+      <mc:AlternateContent xmlns:mc="http://schemas.openxmlformats.org/markup-compatibility/2006" xmlns:a14="http://schemas.microsoft.com/office/drawing/2010/main">
+        <mc:Choice Requires="a14">
           <p:sp>
             <p:nvSpPr>
               <p:cNvPr id="28" name="method-formula">
@@ -5720,11 +5718,12 @@
                     </m:oMath>
                   </m:oMathPara>
                 </a14:m>
+                <a:endParaRPr/>
               </a:p>
             </p:txBody>
           </p:sp>
         </mc:Choice>
-        <mc:Fallback>
+        <mc:Fallback xmlns="">
           <p:sp>
             <p:nvSpPr>
               <p:cNvPr id="28" name="method-formula">
@@ -6732,8 +6731,8 @@
           </a:p>
         </p:txBody>
       </p:sp>
-      <mc:AlternateContent xmlns:mc="http://schemas.openxmlformats.org/markup-compatibility/2006">
-        <mc:Choice xmlns:a14="http://schemas.microsoft.com/office/drawing/2010/main" Requires="a14">
+      <mc:AlternateContent xmlns:mc="http://schemas.openxmlformats.org/markup-compatibility/2006" xmlns:a14="http://schemas.microsoft.com/office/drawing/2010/main">
+        <mc:Choice Requires="a14">
           <p:sp>
             <p:nvSpPr>
               <p:cNvPr id="48" name="method-detail">
@@ -6998,7 +6997,7 @@
             </p:txBody>
           </p:sp>
         </mc:Choice>
-        <mc:Fallback>
+        <mc:Fallback xmlns="">
           <p:sp>
             <p:nvSpPr>
               <p:cNvPr id="48" name="method-detail">
@@ -9160,8 +9159,8 @@
           </a:p>
         </p:txBody>
       </p:sp>
-      <mc:AlternateContent xmlns:mc="http://schemas.openxmlformats.org/markup-compatibility/2006">
-        <mc:Choice xmlns:a14="http://schemas.microsoft.com/office/drawing/2010/main" Requires="a14">
+      <mc:AlternateContent xmlns:mc="http://schemas.openxmlformats.org/markup-compatibility/2006" xmlns:a14="http://schemas.microsoft.com/office/drawing/2010/main">
+        <mc:Choice Requires="a14">
           <p:sp>
             <p:nvSpPr>
               <p:cNvPr id="93" name="evidence-body-2">
@@ -9263,7 +9262,7 @@
             </p:txBody>
           </p:sp>
         </mc:Choice>
-        <mc:Fallback>
+        <mc:Fallback xmlns="">
           <p:sp>
             <p:nvSpPr>
               <p:cNvPr id="93" name="evidence-body-2">

</xml_diff>